<commit_message>
Update models.json to switch to GitHub Copilot's Claude Sonnet 4.6, enhance contract document with detailed executive summary, and normalize invoice CSV format. Additionally, several binary files were updated, and multiple image files were deleted.
</commit_message>
<xml_diff>
--- a/outputs/deck_normalized.pptx
+++ b/outputs/deck_normalized.pptx
@@ -3113,14 +3113,7 @@
         <p:txBody>
           <a:bodyPr/>
           <a:lstStyle/>
-          <a:p>
-            <a:r>
-              <a:rPr sz="3600" b="1">
-                <a:latin typeface="Arial"/>
-              </a:rPr>
-              <a:t/>
-            </a:r>
-          </a:p>
+          <a:p/>
         </p:txBody>
       </p:sp>
       <p:sp>
@@ -3151,6 +3144,9 @@
               </a:defRPr>
             </a:pPr>
             <a:r>
+              <a:rPr b="1" sz="3600">
+                <a:latin typeface="Arial"/>
+              </a:rPr>
               <a:t>Introduction</a:t>
             </a:r>
           </a:p>
@@ -3195,8 +3191,8 @@
         </p:nvSpPr>
         <p:spPr>
           <a:xfrm>
-            <a:off x="457200" y="6217920"/>
-            <a:ext cx="8229600" cy="457200"/>
+            <a:off x="0" y="6492240"/>
+            <a:ext cx="9144000" cy="365760"/>
           </a:xfrm>
           <a:prstGeom prst="rect">
             <a:avLst/>
@@ -3209,40 +3205,9 @@
           </a:bodyPr>
           <a:lstStyle/>
           <a:p>
-            <a:pPr>
-              <a:defRPr sz="1000"/>
-            </a:pPr>
-            <a:r>
-              <a:t>Confidential — 1 of 12</a:t>
-            </a:r>
-          </a:p>
-        </p:txBody>
-      </p:sp>
-      <p:sp>
-        <p:nvSpPr>
-          <p:cNvPr id="6" name="TextBox 5"/>
-          <p:cNvSpPr txBox="1"/>
-          <p:nvPr/>
-        </p:nvSpPr>
-        <p:spPr>
-          <a:xfrm>
-            <a:off x="0" y="6477000"/>
-            <a:ext cx="9144000" cy="381000"/>
-          </a:xfrm>
-          <a:prstGeom prst="rect">
-            <a:avLst/>
-          </a:prstGeom>
-          <a:noFill/>
-        </p:spPr>
-        <p:txBody>
-          <a:bodyPr wrap="none">
-            <a:spAutoFit/>
-          </a:bodyPr>
-          <a:lstStyle/>
-          <a:p>
             <a:pPr algn="ctr"/>
             <a:r>
-              <a:rPr sz="1000">
+              <a:rPr sz="1000" b="0">
                 <a:latin typeface="Arial"/>
               </a:rPr>
               <a:t>Confidential — 1 of 12</a:t>
@@ -3282,14 +3247,7 @@
         <p:txBody>
           <a:bodyPr/>
           <a:lstStyle/>
-          <a:p>
-            <a:r>
-              <a:rPr sz="3600" b="1">
-                <a:latin typeface="Arial"/>
-              </a:rPr>
-              <a:t/>
-            </a:r>
-          </a:p>
+          <a:p/>
         </p:txBody>
       </p:sp>
       <p:sp>
@@ -3320,6 +3278,9 @@
               </a:defRPr>
             </a:pPr>
             <a:r>
+              <a:rPr b="1" sz="3600">
+                <a:latin typeface="Arial"/>
+              </a:rPr>
               <a:t>Metrics</a:t>
             </a:r>
           </a:p>
@@ -3364,8 +3325,8 @@
         </p:nvSpPr>
         <p:spPr>
           <a:xfrm>
-            <a:off x="0" y="6477000"/>
-            <a:ext cx="9144000" cy="381000"/>
+            <a:off x="0" y="6492240"/>
+            <a:ext cx="9144000" cy="365760"/>
           </a:xfrm>
           <a:prstGeom prst="rect">
             <a:avLst/>
@@ -3380,7 +3341,7 @@
           <a:p>
             <a:pPr algn="ctr"/>
             <a:r>
-              <a:rPr sz="1000">
+              <a:rPr sz="1000" b="0">
                 <a:latin typeface="Arial"/>
               </a:rPr>
               <a:t>Confidential — 10 of 12</a:t>
@@ -3420,14 +3381,7 @@
         <p:txBody>
           <a:bodyPr/>
           <a:lstStyle/>
-          <a:p>
-            <a:r>
-              <a:rPr sz="3600" b="1">
-                <a:latin typeface="Arial"/>
-              </a:rPr>
-              <a:t/>
-            </a:r>
-          </a:p>
+          <a:p/>
         </p:txBody>
       </p:sp>
       <p:sp>
@@ -3453,11 +3407,14 @@
           <a:lstStyle/>
           <a:p>
             <a:pPr>
-              <a:defRPr sz="2800" b="1">
-                <a:latin typeface="Calibri"/>
+              <a:defRPr sz="3600" b="1">
+                <a:latin typeface="Arial"/>
               </a:defRPr>
             </a:pPr>
             <a:r>
+              <a:rPr b="1" sz="3600">
+                <a:latin typeface="Arial"/>
+              </a:rPr>
               <a:t>Next Steps</a:t>
             </a:r>
           </a:p>
@@ -3502,8 +3459,8 @@
         </p:nvSpPr>
         <p:spPr>
           <a:xfrm>
-            <a:off x="0" y="6477000"/>
-            <a:ext cx="9144000" cy="381000"/>
+            <a:off x="0" y="6492240"/>
+            <a:ext cx="9144000" cy="365760"/>
           </a:xfrm>
           <a:prstGeom prst="rect">
             <a:avLst/>
@@ -3518,7 +3475,7 @@
           <a:p>
             <a:pPr algn="ctr"/>
             <a:r>
-              <a:rPr sz="1000">
+              <a:rPr sz="1000" b="0">
                 <a:latin typeface="Arial"/>
               </a:rPr>
               <a:t>Confidential — 11 of 12</a:t>
@@ -3558,14 +3515,7 @@
         <p:txBody>
           <a:bodyPr/>
           <a:lstStyle/>
-          <a:p>
-            <a:r>
-              <a:rPr sz="3600" b="1">
-                <a:latin typeface="Arial"/>
-              </a:rPr>
-              <a:t/>
-            </a:r>
-          </a:p>
+          <a:p/>
         </p:txBody>
       </p:sp>
       <p:sp>
@@ -3591,11 +3541,14 @@
           <a:lstStyle/>
           <a:p>
             <a:pPr>
-              <a:defRPr sz="4400" b="1">
+              <a:defRPr sz="3600" b="1">
                 <a:latin typeface="Arial"/>
               </a:defRPr>
             </a:pPr>
             <a:r>
+              <a:rPr b="1" sz="3600">
+                <a:latin typeface="Arial"/>
+              </a:rPr>
               <a:t>Q&amp;A</a:t>
             </a:r>
           </a:p>
@@ -3640,8 +3593,8 @@
         </p:nvSpPr>
         <p:spPr>
           <a:xfrm>
-            <a:off x="457200" y="6217920"/>
-            <a:ext cx="8229600" cy="457200"/>
+            <a:off x="0" y="6492240"/>
+            <a:ext cx="9144000" cy="365760"/>
           </a:xfrm>
           <a:prstGeom prst="rect">
             <a:avLst/>
@@ -3654,40 +3607,9 @@
           </a:bodyPr>
           <a:lstStyle/>
           <a:p>
-            <a:pPr>
-              <a:defRPr sz="1000"/>
-            </a:pPr>
-            <a:r>
-              <a:t>Confidential — 12 of 12</a:t>
-            </a:r>
-          </a:p>
-        </p:txBody>
-      </p:sp>
-      <p:sp>
-        <p:nvSpPr>
-          <p:cNvPr id="6" name="TextBox 5"/>
-          <p:cNvSpPr txBox="1"/>
-          <p:nvPr/>
-        </p:nvSpPr>
-        <p:spPr>
-          <a:xfrm>
-            <a:off x="0" y="6477000"/>
-            <a:ext cx="9144000" cy="381000"/>
-          </a:xfrm>
-          <a:prstGeom prst="rect">
-            <a:avLst/>
-          </a:prstGeom>
-          <a:noFill/>
-        </p:spPr>
-        <p:txBody>
-          <a:bodyPr wrap="none">
-            <a:spAutoFit/>
-          </a:bodyPr>
-          <a:lstStyle/>
-          <a:p>
             <a:pPr algn="ctr"/>
             <a:r>
-              <a:rPr sz="1000">
+              <a:rPr sz="1000" b="0">
                 <a:latin typeface="Arial"/>
               </a:rPr>
               <a:t>Confidential — 12 of 12</a:t>
@@ -3727,14 +3649,7 @@
         <p:txBody>
           <a:bodyPr/>
           <a:lstStyle/>
-          <a:p>
-            <a:r>
-              <a:rPr sz="3600" b="1">
-                <a:latin typeface="Arial"/>
-              </a:rPr>
-              <a:t/>
-            </a:r>
-          </a:p>
+          <a:p/>
         </p:txBody>
       </p:sp>
       <p:sp>
@@ -3760,11 +3675,14 @@
           <a:lstStyle/>
           <a:p>
             <a:pPr>
-              <a:defRPr sz="2800" b="1">
-                <a:latin typeface="Times New Roman"/>
+              <a:defRPr sz="3600" b="1">
+                <a:latin typeface="Arial"/>
               </a:defRPr>
             </a:pPr>
             <a:r>
+              <a:rPr b="1" sz="3600">
+                <a:latin typeface="Arial"/>
+              </a:rPr>
               <a:t>Overview</a:t>
             </a:r>
           </a:p>
@@ -3809,8 +3727,8 @@
         </p:nvSpPr>
         <p:spPr>
           <a:xfrm>
-            <a:off x="0" y="6477000"/>
-            <a:ext cx="9144000" cy="381000"/>
+            <a:off x="0" y="6492240"/>
+            <a:ext cx="9144000" cy="365760"/>
           </a:xfrm>
           <a:prstGeom prst="rect">
             <a:avLst/>
@@ -3825,7 +3743,7 @@
           <a:p>
             <a:pPr algn="ctr"/>
             <a:r>
-              <a:rPr sz="1000">
+              <a:rPr sz="1000" b="0">
                 <a:latin typeface="Arial"/>
               </a:rPr>
               <a:t>Confidential — 3 of 12</a:t>
@@ -3865,14 +3783,7 @@
         <p:txBody>
           <a:bodyPr/>
           <a:lstStyle/>
-          <a:p>
-            <a:r>
-              <a:rPr sz="3600" b="1">
-                <a:latin typeface="Arial"/>
-              </a:rPr>
-              <a:t/>
-            </a:r>
-          </a:p>
+          <a:p/>
         </p:txBody>
       </p:sp>
       <p:sp>
@@ -3898,11 +3809,14 @@
           <a:lstStyle/>
           <a:p>
             <a:pPr>
-              <a:defRPr sz="4400" b="1">
-                <a:latin typeface="Calibri"/>
+              <a:defRPr sz="3600" b="1">
+                <a:latin typeface="Arial"/>
               </a:defRPr>
             </a:pPr>
             <a:r>
+              <a:rPr b="1" sz="3600">
+                <a:latin typeface="Arial"/>
+              </a:rPr>
               <a:t>Problem Statement</a:t>
             </a:r>
           </a:p>
@@ -3947,8 +3861,8 @@
         </p:nvSpPr>
         <p:spPr>
           <a:xfrm>
-            <a:off x="0" y="6477000"/>
-            <a:ext cx="9144000" cy="381000"/>
+            <a:off x="0" y="6492240"/>
+            <a:ext cx="9144000" cy="365760"/>
           </a:xfrm>
           <a:prstGeom prst="rect">
             <a:avLst/>
@@ -3963,7 +3877,7 @@
           <a:p>
             <a:pPr algn="ctr"/>
             <a:r>
-              <a:rPr sz="1000">
+              <a:rPr sz="1000" b="0">
                 <a:latin typeface="Arial"/>
               </a:rPr>
               <a:t>Confidential — 4 of 12</a:t>
@@ -4003,14 +3917,7 @@
         <p:txBody>
           <a:bodyPr/>
           <a:lstStyle/>
-          <a:p>
-            <a:r>
-              <a:rPr sz="3600" b="1">
-                <a:latin typeface="Arial"/>
-              </a:rPr>
-              <a:t/>
-            </a:r>
-          </a:p>
+          <a:p/>
         </p:txBody>
       </p:sp>
       <p:sp>
@@ -4041,6 +3948,9 @@
               </a:defRPr>
             </a:pPr>
             <a:r>
+              <a:rPr b="1" sz="3600">
+                <a:latin typeface="Arial"/>
+              </a:rPr>
               <a:t>Solution</a:t>
             </a:r>
           </a:p>
@@ -4085,8 +3995,8 @@
         </p:nvSpPr>
         <p:spPr>
           <a:xfrm>
-            <a:off x="0" y="6477000"/>
-            <a:ext cx="9144000" cy="381000"/>
+            <a:off x="0" y="6492240"/>
+            <a:ext cx="9144000" cy="365760"/>
           </a:xfrm>
           <a:prstGeom prst="rect">
             <a:avLst/>
@@ -4101,7 +4011,7 @@
           <a:p>
             <a:pPr algn="ctr"/>
             <a:r>
-              <a:rPr sz="1000">
+              <a:rPr sz="1000" b="0">
                 <a:latin typeface="Arial"/>
               </a:rPr>
               <a:t>Confidential — 5 of 12</a:t>
@@ -4141,14 +4051,7 @@
         <p:txBody>
           <a:bodyPr/>
           <a:lstStyle/>
-          <a:p>
-            <a:r>
-              <a:rPr sz="3600" b="1">
-                <a:latin typeface="Arial"/>
-              </a:rPr>
-              <a:t/>
-            </a:r>
-          </a:p>
+          <a:p/>
         </p:txBody>
       </p:sp>
       <p:sp>
@@ -4174,11 +4077,14 @@
           <a:lstStyle/>
           <a:p>
             <a:pPr>
-              <a:defRPr sz="2400" b="1">
-                <a:latin typeface="Times New Roman"/>
+              <a:defRPr sz="3600" b="1">
+                <a:latin typeface="Arial"/>
               </a:defRPr>
             </a:pPr>
             <a:r>
+              <a:rPr b="1" sz="3600">
+                <a:latin typeface="Arial"/>
+              </a:rPr>
               <a:t>Architecture</a:t>
             </a:r>
           </a:p>
@@ -4223,8 +4129,8 @@
         </p:nvSpPr>
         <p:spPr>
           <a:xfrm>
-            <a:off x="457200" y="6217920"/>
-            <a:ext cx="8229600" cy="457200"/>
+            <a:off x="0" y="6492240"/>
+            <a:ext cx="9144000" cy="365760"/>
           </a:xfrm>
           <a:prstGeom prst="rect">
             <a:avLst/>
@@ -4237,40 +4143,9 @@
           </a:bodyPr>
           <a:lstStyle/>
           <a:p>
-            <a:pPr>
-              <a:defRPr sz="1000"/>
-            </a:pPr>
-            <a:r>
-              <a:t>Confidential — 5 of 12</a:t>
-            </a:r>
-          </a:p>
-        </p:txBody>
-      </p:sp>
-      <p:sp>
-        <p:nvSpPr>
-          <p:cNvPr id="6" name="TextBox 5"/>
-          <p:cNvSpPr txBox="1"/>
-          <p:nvPr/>
-        </p:nvSpPr>
-        <p:spPr>
-          <a:xfrm>
-            <a:off x="0" y="6477000"/>
-            <a:ext cx="9144000" cy="381000"/>
-          </a:xfrm>
-          <a:prstGeom prst="rect">
-            <a:avLst/>
-          </a:prstGeom>
-          <a:noFill/>
-        </p:spPr>
-        <p:txBody>
-          <a:bodyPr wrap="none">
-            <a:spAutoFit/>
-          </a:bodyPr>
-          <a:lstStyle/>
-          <a:p>
             <a:pPr algn="ctr"/>
             <a:r>
-              <a:rPr sz="1000">
+              <a:rPr sz="1000" b="0">
                 <a:latin typeface="Arial"/>
               </a:rPr>
               <a:t>Confidential — 6 of 12</a:t>
@@ -4310,14 +4185,7 @@
         <p:txBody>
           <a:bodyPr/>
           <a:lstStyle/>
-          <a:p>
-            <a:r>
-              <a:rPr sz="3600" b="1">
-                <a:latin typeface="Arial"/>
-              </a:rPr>
-              <a:t/>
-            </a:r>
-          </a:p>
+          <a:p/>
         </p:txBody>
       </p:sp>
       <p:sp>
@@ -4343,11 +4211,14 @@
           <a:lstStyle/>
           <a:p>
             <a:pPr>
-              <a:defRPr sz="4800" b="1">
+              <a:defRPr sz="3600" b="1">
                 <a:latin typeface="Arial"/>
               </a:defRPr>
             </a:pPr>
             <a:r>
+              <a:rPr b="1" sz="3600">
+                <a:latin typeface="Arial"/>
+              </a:rPr>
               <a:t>Implementation</a:t>
             </a:r>
           </a:p>
@@ -4392,8 +4263,8 @@
         </p:nvSpPr>
         <p:spPr>
           <a:xfrm>
-            <a:off x="457200" y="6217920"/>
-            <a:ext cx="8229600" cy="457200"/>
+            <a:off x="0" y="6492240"/>
+            <a:ext cx="9144000" cy="365760"/>
           </a:xfrm>
           <a:prstGeom prst="rect">
             <a:avLst/>
@@ -4406,40 +4277,9 @@
           </a:bodyPr>
           <a:lstStyle/>
           <a:p>
-            <a:pPr>
-              <a:defRPr sz="1000"/>
-            </a:pPr>
-            <a:r>
-              <a:t>Confidential — 6 of 12</a:t>
-            </a:r>
-          </a:p>
-        </p:txBody>
-      </p:sp>
-      <p:sp>
-        <p:nvSpPr>
-          <p:cNvPr id="6" name="TextBox 5"/>
-          <p:cNvSpPr txBox="1"/>
-          <p:nvPr/>
-        </p:nvSpPr>
-        <p:spPr>
-          <a:xfrm>
-            <a:off x="0" y="6477000"/>
-            <a:ext cx="9144000" cy="381000"/>
-          </a:xfrm>
-          <a:prstGeom prst="rect">
-            <a:avLst/>
-          </a:prstGeom>
-          <a:noFill/>
-        </p:spPr>
-        <p:txBody>
-          <a:bodyPr wrap="none">
-            <a:spAutoFit/>
-          </a:bodyPr>
-          <a:lstStyle/>
-          <a:p>
             <a:pPr algn="ctr"/>
             <a:r>
-              <a:rPr sz="1000">
+              <a:rPr sz="1000" b="0">
                 <a:latin typeface="Arial"/>
               </a:rPr>
               <a:t>Confidential — 7 of 12</a:t>
@@ -4479,14 +4319,7 @@
         <p:txBody>
           <a:bodyPr/>
           <a:lstStyle/>
-          <a:p>
-            <a:r>
-              <a:rPr sz="3600" b="1">
-                <a:latin typeface="Arial"/>
-              </a:rPr>
-              <a:t/>
-            </a:r>
-          </a:p>
+          <a:p/>
         </p:txBody>
       </p:sp>
       <p:sp>
@@ -4513,10 +4346,13 @@
           <a:p>
             <a:pPr>
               <a:defRPr sz="3600" b="1">
-                <a:latin typeface="Calibri"/>
+                <a:latin typeface="Arial"/>
               </a:defRPr>
             </a:pPr>
             <a:r>
+              <a:rPr b="1" sz="3600">
+                <a:latin typeface="Arial"/>
+              </a:rPr>
               <a:t>Key Features</a:t>
             </a:r>
           </a:p>
@@ -4561,8 +4397,8 @@
         </p:nvSpPr>
         <p:spPr>
           <a:xfrm>
-            <a:off x="457200" y="6217920"/>
-            <a:ext cx="8229600" cy="457200"/>
+            <a:off x="0" y="6492240"/>
+            <a:ext cx="9144000" cy="365760"/>
           </a:xfrm>
           <a:prstGeom prst="rect">
             <a:avLst/>
@@ -4575,40 +4411,9 @@
           </a:bodyPr>
           <a:lstStyle/>
           <a:p>
-            <a:pPr>
-              <a:defRPr sz="1000"/>
-            </a:pPr>
-            <a:r>
-              <a:t>Confidential — 7 of 12</a:t>
-            </a:r>
-          </a:p>
-        </p:txBody>
-      </p:sp>
-      <p:sp>
-        <p:nvSpPr>
-          <p:cNvPr id="6" name="TextBox 5"/>
-          <p:cNvSpPr txBox="1"/>
-          <p:nvPr/>
-        </p:nvSpPr>
-        <p:spPr>
-          <a:xfrm>
-            <a:off x="0" y="6477000"/>
-            <a:ext cx="9144000" cy="381000"/>
-          </a:xfrm>
-          <a:prstGeom prst="rect">
-            <a:avLst/>
-          </a:prstGeom>
-          <a:noFill/>
-        </p:spPr>
-        <p:txBody>
-          <a:bodyPr wrap="none">
-            <a:spAutoFit/>
-          </a:bodyPr>
-          <a:lstStyle/>
-          <a:p>
             <a:pPr algn="ctr"/>
             <a:r>
-              <a:rPr sz="1000">
+              <a:rPr sz="1000" b="0">
                 <a:latin typeface="Arial"/>
               </a:rPr>
               <a:t>Confidential — 2 of 12</a:t>
@@ -4648,14 +4453,7 @@
         <p:txBody>
           <a:bodyPr/>
           <a:lstStyle/>
-          <a:p>
-            <a:r>
-              <a:rPr sz="3600" b="1">
-                <a:latin typeface="Arial"/>
-              </a:rPr>
-              <a:t/>
-            </a:r>
-          </a:p>
+          <a:p/>
         </p:txBody>
       </p:sp>
       <p:sp>
@@ -4681,11 +4479,14 @@
           <a:lstStyle/>
           <a:p>
             <a:pPr>
-              <a:defRPr sz="3200" b="1">
+              <a:defRPr sz="3600" b="1">
                 <a:latin typeface="Arial"/>
               </a:defRPr>
             </a:pPr>
             <a:r>
+              <a:rPr b="1" sz="3600">
+                <a:latin typeface="Arial"/>
+              </a:rPr>
               <a:t>Demo</a:t>
             </a:r>
           </a:p>
@@ -4730,8 +4531,8 @@
         </p:nvSpPr>
         <p:spPr>
           <a:xfrm>
-            <a:off x="0" y="6477000"/>
-            <a:ext cx="9144000" cy="381000"/>
+            <a:off x="0" y="6492240"/>
+            <a:ext cx="9144000" cy="365760"/>
           </a:xfrm>
           <a:prstGeom prst="rect">
             <a:avLst/>
@@ -4746,7 +4547,7 @@
           <a:p>
             <a:pPr algn="ctr"/>
             <a:r>
-              <a:rPr sz="1000">
+              <a:rPr sz="1000" b="0">
                 <a:latin typeface="Arial"/>
               </a:rPr>
               <a:t>Confidential — 8 of 12</a:t>
@@ -4786,14 +4587,7 @@
         <p:txBody>
           <a:bodyPr/>
           <a:lstStyle/>
-          <a:p>
-            <a:r>
-              <a:rPr sz="3600" b="1">
-                <a:latin typeface="Arial"/>
-              </a:rPr>
-              <a:t/>
-            </a:r>
-          </a:p>
+          <a:p/>
         </p:txBody>
       </p:sp>
       <p:sp>
@@ -4819,11 +4613,14 @@
           <a:lstStyle/>
           <a:p>
             <a:pPr>
-              <a:defRPr sz="4000" b="1">
-                <a:latin typeface="Times New Roman"/>
+              <a:defRPr sz="3600" b="1">
+                <a:latin typeface="Arial"/>
               </a:defRPr>
             </a:pPr>
             <a:r>
+              <a:rPr b="1" sz="3600">
+                <a:latin typeface="Arial"/>
+              </a:rPr>
               <a:t>Results</a:t>
             </a:r>
           </a:p>
@@ -4868,8 +4665,8 @@
         </p:nvSpPr>
         <p:spPr>
           <a:xfrm>
-            <a:off x="0" y="6477000"/>
-            <a:ext cx="9144000" cy="381000"/>
+            <a:off x="0" y="6492240"/>
+            <a:ext cx="9144000" cy="365760"/>
           </a:xfrm>
           <a:prstGeom prst="rect">
             <a:avLst/>
@@ -4884,7 +4681,7 @@
           <a:p>
             <a:pPr algn="ctr"/>
             <a:r>
-              <a:rPr sz="1000">
+              <a:rPr sz="1000" b="0">
                 <a:latin typeface="Arial"/>
               </a:rPr>
               <a:t>Confidential — 9 of 12</a:t>

</xml_diff>